<commit_message>
Polish hackathon README and presentation
Co-authored-by: Copilot <223556219+Copilot@users.noreply.github.com>
</commit_message>
<xml_diff>
--- a/MediscanAI_Presentation.pptx
+++ b/MediscanAI_Presentation.pptx
@@ -5507,76 +5507,6 @@
                 <a:latin typeface="Aptos"/>
               </a:rPr>
               <a:t>Yash Vijay  ?  JECRC Foundation, Jaipur</a:t>
-            </a:r>
-          </a:p>
-        </p:txBody>
-      </p:sp>
-      <p:sp>
-        <p:nvSpPr>
-          <p:cNvPr id="10" name="TextBox 9"/>
-          <p:cNvSpPr txBox="1"/>
-          <p:nvPr/>
-        </p:nvSpPr>
-        <p:spPr>
-          <a:xfrm>
-            <a:off x="7863840" y="3913632"/>
-            <a:ext cx="3017520" cy="182880"/>
-          </a:xfrm>
-          <a:prstGeom prst="rect">
-            <a:avLst/>
-          </a:prstGeom>
-          <a:noFill/>
-        </p:spPr>
-        <p:txBody>
-          <a:bodyPr wrap="square" lIns="36576" rIns="36576" tIns="36576" bIns="36576" anchor="t">
-            <a:spAutoFit/>
-          </a:bodyPr>
-          <a:lstStyle/>
-          <a:p>
-            <a:pPr algn="r"/>
-            <a:r>
-              <a:rPr sz="1000" b="1">
-                <a:solidFill>
-                  <a:srgbClr val="FFA652"/>
-                </a:solidFill>
-                <a:latin typeface="Aptos"/>
-              </a:rPr>
-              <a:t>DEMO VIDEO</a:t>
-            </a:r>
-          </a:p>
-        </p:txBody>
-      </p:sp>
-      <p:sp>
-        <p:nvSpPr>
-          <p:cNvPr id="11" name="TextBox 10"/>
-          <p:cNvSpPr txBox="1"/>
-          <p:nvPr/>
-        </p:nvSpPr>
-        <p:spPr>
-          <a:xfrm>
-            <a:off x="7315200" y="4315968"/>
-            <a:ext cx="3566160" cy="256032"/>
-          </a:xfrm>
-          <a:prstGeom prst="rect">
-            <a:avLst/>
-          </a:prstGeom>
-          <a:noFill/>
-        </p:spPr>
-        <p:txBody>
-          <a:bodyPr wrap="square" lIns="36576" rIns="36576" tIns="36576" bIns="36576" anchor="t">
-            <a:spAutoFit/>
-          </a:bodyPr>
-          <a:lstStyle/>
-          <a:p>
-            <a:pPr algn="r"/>
-            <a:r>
-              <a:rPr sz="1400" b="1">
-                <a:solidFill>
-                  <a:srgbClr val="A4B9CF"/>
-                </a:solidFill>
-                <a:latin typeface="Aptos"/>
-              </a:rPr>
-              <a:t>Add final unlisted YouTube URL</a:t>
             </a:r>
           </a:p>
         </p:txBody>

</xml_diff>